<commit_message>
Replace 39 dead YouTube links across Ch01/12-19
All failing IDs verified via oembed 404 then replaced with working
performance URLs matching each NAWM context. Affected chapters:
Ch01 (1), Ch12 (6), Ch13 (3), Ch14 (5), Ch15 (7), Ch16 (3),
Ch17 (4), Ch18 (3), Ch19 (7).

Co-Authored-By: Claude Opus 4.7 <noreply@anthropic.com>
</commit_message>
<xml_diff>
--- a/Ch12_Instrumental.pptx
+++ b/Ch12_Instrumental.pptx
@@ -3990,7 +3990,7 @@
                 <a:ea typeface="Calibri" pitchFamily="34" charset="-122"/>
                 <a:cs typeface="Calibri" pitchFamily="34" charset="-120"/>
               </a:rPr>
-              <a:t>YouTube: https://www.youtube.com/watch?v=fMPVMFpONRU</a:t>
+              <a:t>YouTube: https://www.youtube.com/watch?v=Ln7ea-5dsoo</a:t>
             </a:r>
             <a:endParaRPr lang="en-US" sz="1800" dirty="0"/>
           </a:p>
@@ -4823,7 +4823,7 @@
                 <a:ea typeface="Calibri" pitchFamily="34" charset="-122"/>
                 <a:cs typeface="Calibri" pitchFamily="34" charset="-120"/>
               </a:rPr>
-              <a:t>YouTube: https://www.youtube.com/watch?v=8E7zcsal98U</a:t>
+              <a:t>YouTube: https://www.youtube.com/watch?v=xKAeB5nDCmA</a:t>
             </a:r>
             <a:endParaRPr lang="en-US" sz="1800" dirty="0"/>
           </a:p>
@@ -6043,7 +6043,7 @@
                 <a:ea typeface="Calibri" pitchFamily="34" charset="-122"/>
                 <a:cs typeface="Calibri" pitchFamily="34" charset="-120"/>
               </a:rPr>
-              <a:t>YouTube: https://www.youtube.com/watch?v=5C1gfQ3I_8E</a:t>
+              <a:t>YouTube: https://www.youtube.com/watch?v=DD7luwIuM40</a:t>
             </a:r>
             <a:endParaRPr lang="en-US" sz="1800" dirty="0"/>
           </a:p>
@@ -6876,7 +6876,7 @@
                 <a:ea typeface="Calibri" pitchFamily="34" charset="-122"/>
                 <a:cs typeface="Calibri" pitchFamily="34" charset="-120"/>
               </a:rPr>
-              <a:t>YouTube: https://www.youtube.com/watch?v=Ud0WKFMiZfg</a:t>
+              <a:t>YouTube: https://www.youtube.com/watch?v=DRYBJDFxQo8</a:t>
             </a:r>
             <a:endParaRPr lang="en-US" sz="1800" dirty="0"/>
           </a:p>
@@ -10388,7 +10388,7 @@
                 <a:ea typeface="Calibri" pitchFamily="34" charset="-122"/>
                 <a:cs typeface="Calibri" pitchFamily="34" charset="-120"/>
               </a:rPr>
-              <a:t>YouTube: https://www.youtube.com/watch?v=U_FMsBmtI7g</a:t>
+              <a:t>YouTube: https://www.youtube.com/watch?v=QXRITlQBitc</a:t>
             </a:r>
             <a:endParaRPr lang="en-US" sz="1800" dirty="0"/>
           </a:p>
@@ -10834,7 +10834,7 @@
                 <a:ea typeface="Calibri" pitchFamily="34" charset="-122"/>
                 <a:cs typeface="Calibri" pitchFamily="34" charset="-120"/>
               </a:rPr>
-              <a:t>YouTube: https://www.youtube.com/watch?v=Xsuz4p3PdkM</a:t>
+              <a:t>YouTube: https://www.youtube.com/watch?v=Xf8oWn1Hj_8</a:t>
             </a:r>
             <a:endParaRPr lang="en-US" sz="1800" dirty="0"/>
           </a:p>
@@ -13002,7 +13002,7 @@
                 <a:ea typeface="Calibri" pitchFamily="34" charset="-122"/>
                 <a:cs typeface="Calibri" pitchFamily="34" charset="-120"/>
               </a:rPr>
-              <a:t>youtube.com/watch?v=fMPVMFpONRU</a:t>
+              <a:t>youtube.com/watch?v=Ln7ea-5dsoo</a:t>
             </a:r>
             <a:endParaRPr lang="en-US" sz="1800" dirty="0"/>
           </a:p>
@@ -13139,7 +13139,7 @@
                 <a:ea typeface="Calibri" pitchFamily="34" charset="-122"/>
                 <a:cs typeface="Calibri" pitchFamily="34" charset="-120"/>
               </a:rPr>
-              <a:t>youtube.com/watch?v=8E7zcsal98U</a:t>
+              <a:t>youtube.com/watch?v=xKAeB5nDCmA</a:t>
             </a:r>
             <a:endParaRPr lang="en-US" sz="1800" dirty="0"/>
           </a:p>
@@ -13276,7 +13276,7 @@
                 <a:ea typeface="Calibri" pitchFamily="34" charset="-122"/>
                 <a:cs typeface="Calibri" pitchFamily="34" charset="-120"/>
               </a:rPr>
-              <a:t>youtube.com/watch?v=5C1gfQ3I_8E</a:t>
+              <a:t>youtube.com/watch?v=DD7luwIuM40</a:t>
             </a:r>
             <a:endParaRPr lang="en-US" sz="1800" dirty="0"/>
           </a:p>
@@ -13413,7 +13413,7 @@
                 <a:ea typeface="Calibri" pitchFamily="34" charset="-122"/>
                 <a:cs typeface="Calibri" pitchFamily="34" charset="-120"/>
               </a:rPr>
-              <a:t>youtube.com/watch?v=Ud0WKFMiZfg</a:t>
+              <a:t>youtube.com/watch?v=DRYBJDFxQo8</a:t>
             </a:r>
             <a:endParaRPr lang="en-US" sz="1800" dirty="0"/>
           </a:p>
@@ -13687,7 +13687,7 @@
                 <a:ea typeface="Calibri" pitchFamily="34" charset="-122"/>
                 <a:cs typeface="Calibri" pitchFamily="34" charset="-120"/>
               </a:rPr>
-              <a:t>youtube.com/watch?v=U_FMsBmtI7g</a:t>
+              <a:t>youtube.com/watch?v=QXRITlQBitc</a:t>
             </a:r>
             <a:endParaRPr lang="en-US" sz="1800" dirty="0"/>
           </a:p>
@@ -13824,7 +13824,7 @@
                 <a:ea typeface="Calibri" pitchFamily="34" charset="-122"/>
                 <a:cs typeface="Calibri" pitchFamily="34" charset="-120"/>
               </a:rPr>
-              <a:t>youtube.com/watch?v=Xsuz4p3PdkM</a:t>
+              <a:t>youtube.com/watch?v=Xf8oWn1Hj_8</a:t>
             </a:r>
             <a:endParaRPr lang="en-US" sz="1800" dirty="0"/>
           </a:p>

</xml_diff>